<commit_message>
Name the tagged version in the deck's criteria notes
Both acceptance-criteria pages quote where the results stand, and their wording said "at this
commit" while the footer on every page names `tag submission-2026-09-29`. The two disagreed
about what the version is, and the deck is the one a marker reads first; the notes now name
the tag as well.

The numbers are unchanged, and they are the test plan's own summary rather than a second
count kept in the deck: 19 of the 21 scenarios have a recorded result - 12 pass, 7 pass in
part; TC-13 and TC-16 have never been run; eight of the ten acceptance criteria have a fully
passing result.

Nothing else in the deck changes. The same eight slides, the same five figures (the embedded
PNGs are byte-identical to the ones in `models/exports/`), the same criteria table with its
requirement and business-rule links.
</commit_message>
<xml_diff>
--- a/HPRTAS - Five Executable Processes.pptx
+++ b/HPRTAS - Five Executable Processes.pptx
@@ -6399,7 +6399,7 @@
                 </a:solidFill>
                 <a:latin typeface="Segoe UI"/>
               </a:rPr>
-              <a:t>Each criterion is measurable because it states the condition to be met, and because it is linked to the requirement and the business rule it comes from. The scenarios beside it are the ones that measure it, and the result is the one recorded in the test plan's execution record at this commit.</a:t>
+              <a:t>Each criterion is measurable because it states the condition to be met, and because it is linked to the requirement and the business rule it comes from. The scenarios beside it are the ones that measure it, and the result is the one recorded in the test plan's execution record at this version.</a:t>
             </a:r>
           </a:p>
         </p:txBody>
@@ -7550,7 +7550,7 @@
                 </a:solidFill>
                 <a:latin typeface="Segoe UI"/>
               </a:rPr>
-              <a:t>Recorded at this commit: 19 of the 21 scenarios have a result - 12 pass and 7 pass in part; TC-13 and TC-16 have not been run. Eight criteria have a fully passing result: AC-01 to AC-05, AC-08, AC-09 and AC-10. Not demonstrated at this version: no authentication, no enforced role separation and no audit trail (DEF-07), and no form submitted by a signed-in user (DEF-08).</a:t>
+              <a:t>Recorded at tag submission-2026-09-29: 19 of the 21 scenarios have a result - 12 pass, 7 pass in part; TC-13 and TC-16 have never been run. 8 of the ten criteria have a fully passing result: AC-01, AC-02, AC-03, AC-04, AC-05, AC-08, AC-09 and AC-10. Not demonstrated at this version: no authentication, no enforced role separation and no audit trail (DEF-07), and no form submitted by a signed-in user (DEF-08).</a:t>
             </a:r>
           </a:p>
         </p:txBody>

</xml_diff>